<commit_message>
add table contast check and no flag 'fill' changes to fill nan
</commit_message>
<xml_diff>
--- a/tests/goldens/build-pptx/clone-tiny.pptx
+++ b/tests/goldens/build-pptx/clone-tiny.pptx
@@ -1,6 +1,6 @@
 
 <file path=ppt/presentation.xml><?xml version="1.0" encoding="utf-8"?>
-<p:presentation xmlns:a="http://schemas.openxmlformats.org/drawingml/2006/main" xmlns:r="http://schemas.openxmlformats.org/officeDocument/2006/relationships" xmlns:p="http://schemas.openxmlformats.org/presentationml/2006/main" saveSubsetFonts="1" autoCompressPictures="0">
+<p:presentation xmlns:p="http://schemas.openxmlformats.org/presentationml/2006/main" xmlns:r="http://schemas.openxmlformats.org/officeDocument/2006/relationships" xmlns:a="http://schemas.openxmlformats.org/drawingml/2006/main" saveSubsetFonts="1" autoCompressPictures="0">
   <p:sldMasterIdLst>
     <p:sldMasterId id="2147483648" r:id="rId1"/>
   </p:sldMasterIdLst>
@@ -109,7 +109,7 @@
 </file>
 
 <file path=ppt/slideLayouts/slideLayout1.xml><?xml version="1.0" encoding="utf-8"?>
-<p:sldLayout xmlns:a="http://schemas.openxmlformats.org/drawingml/2006/main" xmlns:r="http://schemas.openxmlformats.org/officeDocument/2006/relationships" xmlns:p="http://schemas.openxmlformats.org/presentationml/2006/main" type="title" preserve="1">
+<p:sldLayout xmlns:p="http://schemas.openxmlformats.org/presentationml/2006/main" xmlns:a="http://schemas.openxmlformats.org/drawingml/2006/main" xmlns:ns1="http://schemas.microsoft.com/office/powerpoint/2010/main" type="title" preserve="1">
   <p:cSld name="Title Slide">
     <p:spTree>
       <p:nvGrpSpPr>
@@ -340,7 +340,7 @@
     </p:spTree>
     <p:extLst>
       <p:ext uri="{BB962C8B-B14F-4D97-AF65-F5344CB8AC3E}">
-        <p14:creationId xmlns:p14="http://schemas.microsoft.com/office/powerpoint/2010/main" val="3168075583"/>
+        <ns1:creationId val="3168075583"/>
       </p:ext>
     </p:extLst>
   </p:cSld>
@@ -351,7 +351,7 @@
 </file>
 
 <file path=ppt/slideLayouts/slideLayout10.xml><?xml version="1.0" encoding="utf-8"?>
-<p:sldLayout xmlns:a="http://schemas.openxmlformats.org/drawingml/2006/main" xmlns:r="http://schemas.openxmlformats.org/officeDocument/2006/relationships" xmlns:p="http://schemas.openxmlformats.org/presentationml/2006/main" type="vertTx" preserve="1">
+<p:sldLayout xmlns:p="http://schemas.openxmlformats.org/presentationml/2006/main" xmlns:a="http://schemas.openxmlformats.org/drawingml/2006/main" xmlns:ns1="http://schemas.microsoft.com/office/powerpoint/2010/main" type="vertTx" preserve="1">
   <p:cSld name="Title and Vertical Text">
     <p:spTree>
       <p:nvGrpSpPr>
@@ -510,7 +510,7 @@
     </p:spTree>
     <p:extLst>
       <p:ext uri="{BB962C8B-B14F-4D97-AF65-F5344CB8AC3E}">
-        <p14:creationId xmlns:p14="http://schemas.microsoft.com/office/powerpoint/2010/main" val="2910927964"/>
+        <ns1:creationId val="2910927964"/>
       </p:ext>
     </p:extLst>
   </p:cSld>
@@ -521,7 +521,7 @@
 </file>
 
 <file path=ppt/slideLayouts/slideLayout11.xml><?xml version="1.0" encoding="utf-8"?>
-<p:sldLayout xmlns:a="http://schemas.openxmlformats.org/drawingml/2006/main" xmlns:r="http://schemas.openxmlformats.org/officeDocument/2006/relationships" xmlns:p="http://schemas.openxmlformats.org/presentationml/2006/main" type="vertTitleAndTx" preserve="1">
+<p:sldLayout xmlns:p="http://schemas.openxmlformats.org/presentationml/2006/main" xmlns:a="http://schemas.openxmlformats.org/drawingml/2006/main" xmlns:ns1="http://schemas.microsoft.com/office/powerpoint/2010/main" type="vertTitleAndTx" preserve="1">
   <p:cSld name="Vertical Title and Text">
     <p:spTree>
       <p:nvGrpSpPr>
@@ -690,7 +690,7 @@
     </p:spTree>
     <p:extLst>
       <p:ext uri="{BB962C8B-B14F-4D97-AF65-F5344CB8AC3E}">
-        <p14:creationId xmlns:p14="http://schemas.microsoft.com/office/powerpoint/2010/main" val="3612223792"/>
+        <ns1:creationId val="3612223792"/>
       </p:ext>
     </p:extLst>
   </p:cSld>
@@ -701,7 +701,7 @@
 </file>
 
 <file path=ppt/slideLayouts/slideLayout2.xml><?xml version="1.0" encoding="utf-8"?>
-<p:sldLayout xmlns:a="http://schemas.openxmlformats.org/drawingml/2006/main" xmlns:r="http://schemas.openxmlformats.org/officeDocument/2006/relationships" xmlns:p="http://schemas.openxmlformats.org/presentationml/2006/main" type="obj" preserve="1">
+<p:sldLayout xmlns:p="http://schemas.openxmlformats.org/presentationml/2006/main" xmlns:a="http://schemas.openxmlformats.org/drawingml/2006/main" xmlns:ns1="http://schemas.microsoft.com/office/powerpoint/2010/main" type="obj" preserve="1">
   <p:cSld name="Title and Content">
     <p:spTree>
       <p:nvGrpSpPr>
@@ -860,7 +860,7 @@
     </p:spTree>
     <p:extLst>
       <p:ext uri="{BB962C8B-B14F-4D97-AF65-F5344CB8AC3E}">
-        <p14:creationId xmlns:p14="http://schemas.microsoft.com/office/powerpoint/2010/main" val="2614314258"/>
+        <ns1:creationId val="2614314258"/>
       </p:ext>
     </p:extLst>
   </p:cSld>
@@ -871,7 +871,7 @@
 </file>
 
 <file path=ppt/slideLayouts/slideLayout3.xml><?xml version="1.0" encoding="utf-8"?>
-<p:sldLayout xmlns:a="http://schemas.openxmlformats.org/drawingml/2006/main" xmlns:r="http://schemas.openxmlformats.org/officeDocument/2006/relationships" xmlns:p="http://schemas.openxmlformats.org/presentationml/2006/main" type="secHead" preserve="1">
+<p:sldLayout xmlns:p="http://schemas.openxmlformats.org/presentationml/2006/main" xmlns:a="http://schemas.openxmlformats.org/drawingml/2006/main" xmlns:ns1="http://schemas.microsoft.com/office/powerpoint/2010/main" type="secHead" preserve="1">
   <p:cSld name="Section Header">
     <p:spTree>
       <p:nvGrpSpPr>
@@ -1106,7 +1106,7 @@
     </p:spTree>
     <p:extLst>
       <p:ext uri="{BB962C8B-B14F-4D97-AF65-F5344CB8AC3E}">
-        <p14:creationId xmlns:p14="http://schemas.microsoft.com/office/powerpoint/2010/main" val="960648375"/>
+        <ns1:creationId val="960648375"/>
       </p:ext>
     </p:extLst>
   </p:cSld>
@@ -1117,7 +1117,7 @@
 </file>
 
 <file path=ppt/slideLayouts/slideLayout4.xml><?xml version="1.0" encoding="utf-8"?>
-<p:sldLayout xmlns:a="http://schemas.openxmlformats.org/drawingml/2006/main" xmlns:r="http://schemas.openxmlformats.org/officeDocument/2006/relationships" xmlns:p="http://schemas.openxmlformats.org/presentationml/2006/main" type="twoObj" preserve="1">
+<p:sldLayout xmlns:p="http://schemas.openxmlformats.org/presentationml/2006/main" xmlns:a="http://schemas.openxmlformats.org/drawingml/2006/main" xmlns:ns1="http://schemas.microsoft.com/office/powerpoint/2010/main" type="twoObj" preserve="1">
   <p:cSld name="Two Content">
     <p:spTree>
       <p:nvGrpSpPr>
@@ -1394,7 +1394,7 @@
     </p:spTree>
     <p:extLst>
       <p:ext uri="{BB962C8B-B14F-4D97-AF65-F5344CB8AC3E}">
-        <p14:creationId xmlns:p14="http://schemas.microsoft.com/office/powerpoint/2010/main" val="2782244947"/>
+        <ns1:creationId val="2782244947"/>
       </p:ext>
     </p:extLst>
   </p:cSld>
@@ -1405,7 +1405,7 @@
 </file>
 
 <file path=ppt/slideLayouts/slideLayout5.xml><?xml version="1.0" encoding="utf-8"?>
-<p:sldLayout xmlns:a="http://schemas.openxmlformats.org/drawingml/2006/main" xmlns:r="http://schemas.openxmlformats.org/officeDocument/2006/relationships" xmlns:p="http://schemas.openxmlformats.org/presentationml/2006/main" type="twoTxTwoObj" preserve="1">
+<p:sldLayout xmlns:p="http://schemas.openxmlformats.org/presentationml/2006/main" xmlns:a="http://schemas.openxmlformats.org/drawingml/2006/main" xmlns:ns1="http://schemas.microsoft.com/office/powerpoint/2010/main" type="twoTxTwoObj" preserve="1">
   <p:cSld name="Comparison">
     <p:spTree>
       <p:nvGrpSpPr>
@@ -1816,7 +1816,7 @@
     </p:spTree>
     <p:extLst>
       <p:ext uri="{BB962C8B-B14F-4D97-AF65-F5344CB8AC3E}">
-        <p14:creationId xmlns:p14="http://schemas.microsoft.com/office/powerpoint/2010/main" val="990158736"/>
+        <ns1:creationId val="990158736"/>
       </p:ext>
     </p:extLst>
   </p:cSld>
@@ -1827,7 +1827,7 @@
 </file>
 
 <file path=ppt/slideLayouts/slideLayout6.xml><?xml version="1.0" encoding="utf-8"?>
-<p:sldLayout xmlns:a="http://schemas.openxmlformats.org/drawingml/2006/main" xmlns:r="http://schemas.openxmlformats.org/officeDocument/2006/relationships" xmlns:p="http://schemas.openxmlformats.org/presentationml/2006/main" type="titleOnly" preserve="1">
+<p:sldLayout xmlns:p="http://schemas.openxmlformats.org/presentationml/2006/main" xmlns:a="http://schemas.openxmlformats.org/drawingml/2006/main" xmlns:ns1="http://schemas.microsoft.com/office/powerpoint/2010/main" type="titleOnly" preserve="1">
   <p:cSld name="Title Only">
     <p:spTree>
       <p:nvGrpSpPr>
@@ -1934,7 +1934,7 @@
     </p:spTree>
     <p:extLst>
       <p:ext uri="{BB962C8B-B14F-4D97-AF65-F5344CB8AC3E}">
-        <p14:creationId xmlns:p14="http://schemas.microsoft.com/office/powerpoint/2010/main" val="727027711"/>
+        <ns1:creationId val="727027711"/>
       </p:ext>
     </p:extLst>
   </p:cSld>
@@ -1945,7 +1945,7 @@
 </file>
 
 <file path=ppt/slideLayouts/slideLayout7.xml><?xml version="1.0" encoding="utf-8"?>
-<p:sldLayout xmlns:a="http://schemas.openxmlformats.org/drawingml/2006/main" xmlns:r="http://schemas.openxmlformats.org/officeDocument/2006/relationships" xmlns:p="http://schemas.openxmlformats.org/presentationml/2006/main" type="blank" preserve="1">
+<p:sldLayout xmlns:p="http://schemas.openxmlformats.org/presentationml/2006/main" xmlns:a="http://schemas.openxmlformats.org/drawingml/2006/main" xmlns:ns1="http://schemas.microsoft.com/office/powerpoint/2010/main" type="blank" preserve="1">
   <p:cSld name="Blank">
     <p:spTree>
       <p:nvGrpSpPr>
@@ -2029,7 +2029,7 @@
     </p:spTree>
     <p:extLst>
       <p:ext uri="{BB962C8B-B14F-4D97-AF65-F5344CB8AC3E}">
-        <p14:creationId xmlns:p14="http://schemas.microsoft.com/office/powerpoint/2010/main" val="1212999818"/>
+        <ns1:creationId val="1212999818"/>
       </p:ext>
     </p:extLst>
   </p:cSld>
@@ -2040,7 +2040,7 @@
 </file>
 
 <file path=ppt/slideLayouts/slideLayout8.xml><?xml version="1.0" encoding="utf-8"?>
-<p:sldLayout xmlns:a="http://schemas.openxmlformats.org/drawingml/2006/main" xmlns:r="http://schemas.openxmlformats.org/officeDocument/2006/relationships" xmlns:p="http://schemas.openxmlformats.org/presentationml/2006/main" type="objTx" preserve="1">
+<p:sldLayout xmlns:p="http://schemas.openxmlformats.org/presentationml/2006/main" xmlns:a="http://schemas.openxmlformats.org/drawingml/2006/main" xmlns:ns1="http://schemas.microsoft.com/office/powerpoint/2010/main" type="objTx" preserve="1">
   <p:cSld name="Content with Caption">
     <p:spTree>
       <p:nvGrpSpPr>
@@ -2306,7 +2306,7 @@
     </p:spTree>
     <p:extLst>
       <p:ext uri="{BB962C8B-B14F-4D97-AF65-F5344CB8AC3E}">
-        <p14:creationId xmlns:p14="http://schemas.microsoft.com/office/powerpoint/2010/main" val="1840726560"/>
+        <ns1:creationId val="1840726560"/>
       </p:ext>
     </p:extLst>
   </p:cSld>
@@ -2317,7 +2317,7 @@
 </file>
 
 <file path=ppt/slideLayouts/slideLayout9.xml><?xml version="1.0" encoding="utf-8"?>
-<p:sldLayout xmlns:a="http://schemas.openxmlformats.org/drawingml/2006/main" xmlns:r="http://schemas.openxmlformats.org/officeDocument/2006/relationships" xmlns:p="http://schemas.openxmlformats.org/presentationml/2006/main" type="picTx" preserve="1">
+<p:sldLayout xmlns:p="http://schemas.openxmlformats.org/presentationml/2006/main" xmlns:a="http://schemas.openxmlformats.org/drawingml/2006/main" xmlns:ns1="http://schemas.microsoft.com/office/powerpoint/2010/main" type="picTx" preserve="1">
   <p:cSld name="Picture with Caption">
     <p:spTree>
       <p:nvGrpSpPr>
@@ -2559,7 +2559,7 @@
     </p:spTree>
     <p:extLst>
       <p:ext uri="{BB962C8B-B14F-4D97-AF65-F5344CB8AC3E}">
-        <p14:creationId xmlns:p14="http://schemas.microsoft.com/office/powerpoint/2010/main" val="3889236939"/>
+        <ns1:creationId val="3889236939"/>
       </p:ext>
     </p:extLst>
   </p:cSld>
@@ -2570,7 +2570,7 @@
 </file>
 
 <file path=ppt/slideMasters/slideMaster1.xml><?xml version="1.0" encoding="utf-8"?>
-<p:sldMaster xmlns:a="http://schemas.openxmlformats.org/drawingml/2006/main" xmlns:r="http://schemas.openxmlformats.org/officeDocument/2006/relationships" xmlns:p="http://schemas.openxmlformats.org/presentationml/2006/main">
+<p:sldMaster xmlns:p="http://schemas.openxmlformats.org/presentationml/2006/main" xmlns:a="http://schemas.openxmlformats.org/drawingml/2006/main" xmlns:ns1="http://schemas.microsoft.com/office/powerpoint/2010/main" xmlns:r="http://schemas.openxmlformats.org/officeDocument/2006/relationships">
   <p:cSld>
     <p:bg>
       <p:bgRef idx="1001">
@@ -2808,7 +2808,7 @@
     </p:spTree>
     <p:extLst>
       <p:ext uri="{BB962C8B-B14F-4D97-AF65-F5344CB8AC3E}">
-        <p14:creationId xmlns:p14="http://schemas.microsoft.com/office/powerpoint/2010/main" val="2209977519"/>
+        <ns1:creationId val="2209977519"/>
       </p:ext>
     </p:extLst>
   </p:cSld>
@@ -3080,7 +3080,7 @@
 </file>
 
 <file path=ppt/slides/slide6.xml><?xml version="1.0" encoding="utf-8"?>
-<p:sld xmlns:a="http://schemas.openxmlformats.org/drawingml/2006/main" xmlns:p="http://schemas.openxmlformats.org/presentationml/2006/main" xmlns:r="http://schemas.openxmlformats.org/officeDocument/2006/relationships">
+<p:sld xmlns:p="http://schemas.openxmlformats.org/presentationml/2006/main" xmlns:a="http://schemas.openxmlformats.org/drawingml/2006/main" xmlns:r="http://schemas.openxmlformats.org/officeDocument/2006/relationships">
   <p:cSld>
     <p:spTree>
       <p:nvGrpSpPr>
@@ -3130,7 +3130,7 @@
           <a:noFill/>
         </p:spPr>
         <p:txBody>
-          <a:bodyPr wrap="square" lIns="0" rIns="0" tIns="0" bIns="0">
+          <a:bodyPr wrap="square" lIns="0" tIns="0" rIns="0" bIns="0">
             <a:spAutoFit/>
           </a:bodyPr>
           <a:lstStyle/>
@@ -3156,7 +3156,7 @@
 </file>
 
 <file path=ppt/slides/slide7.xml><?xml version="1.0" encoding="utf-8"?>
-<p:sld xmlns:a="http://schemas.openxmlformats.org/drawingml/2006/main" xmlns:p="http://schemas.openxmlformats.org/presentationml/2006/main" xmlns:r="http://schemas.openxmlformats.org/officeDocument/2006/relationships">
+<p:sld xmlns:p="http://schemas.openxmlformats.org/presentationml/2006/main" xmlns:a="http://schemas.openxmlformats.org/drawingml/2006/main">
   <p:cSld>
     <p:spTree>
       <p:nvGrpSpPr>
@@ -3199,7 +3199,9 @@
                       </a:r>
                     </a:p>
                   </a:txBody>
-                  <a:tcPr anchor="ctr" marL="47625" marR="47625" marT="22860" marB="22860"/>
+                  <a:tcPr anchor="ctr" marL="47625" marR="47625" marT="22860" marB="22860">
+                    <a:noFill/>
+                  </a:tcPr>
                 </a:tc>
                 <a:tc>
                   <a:txBody>
@@ -3212,7 +3214,9 @@
                       </a:r>
                     </a:p>
                   </a:txBody>
-                  <a:tcPr anchor="ctr" marL="47625" marR="47625" marT="22860" marB="22860"/>
+                  <a:tcPr anchor="ctr" marL="47625" marR="47625" marT="22860" marB="22860">
+                    <a:noFill/>
+                  </a:tcPr>
                 </a:tc>
               </a:tr>
               <a:tr h="1143000">
@@ -3227,7 +3231,9 @@
                       </a:r>
                     </a:p>
                   </a:txBody>
-                  <a:tcPr anchor="ctr" marL="47625" marR="47625" marT="22860" marB="22860"/>
+                  <a:tcPr anchor="ctr" marL="47625" marR="47625" marT="22860" marB="22860">
+                    <a:noFill/>
+                  </a:tcPr>
                 </a:tc>
                 <a:tc>
                   <a:txBody>
@@ -3240,7 +3246,9 @@
                       </a:r>
                     </a:p>
                   </a:txBody>
-                  <a:tcPr anchor="ctr" marL="47625" marR="47625" marT="22860" marB="22860"/>
+                  <a:tcPr anchor="ctr" marL="47625" marR="47625" marT="22860" marB="22860">
+                    <a:noFill/>
+                  </a:tcPr>
                 </a:tc>
               </a:tr>
             </a:tbl>

</xml_diff>